<commit_message>
Setup Argentina: se verifica el sitio y se suma la captura anotada
La sesion anterior lo armo sin navegador y dejo tres pendientes. Ahora:
el sitio abierto (ingles por defecto, espanol en /es/, blog todavia sin
notas), la campana confirmada a Estados Unidos y un slide 3 con la captura.
Hook y cierre sin bajada, como los edita Mateo. El caption deja de hablar
de una segunda web y de que el negocio crecio, que no se puede verificar.
Solo falta que Agus autorice.

Co-Authored-By: Claude Opus 5 <noreply@anthropic.com>
</commit_message>
<xml_diff>
--- a/contenido/carruseles/06-setup-argentina/editable-canva.pptx
+++ b/contenido/carruseles/06-setup-argentina/editable-canva.pptx
@@ -8,6 +8,7 @@
     <p:sldId id="256" r:id="rId7"/>
     <p:sldId id="257" r:id="rId8"/>
     <p:sldId id="258" r:id="rId9"/>
+    <p:sldId id="259" r:id="rId10"/>
   </p:sldIdLst>
   <p:sldSz cx="10287000" cy="12858750" type="screen4x3"/>
   <p:notesSz cx="6858000" cy="9144000"/>
@@ -3106,7 +3107,7 @@
         </p:nvSpPr>
         <p:spPr>
           <a:xfrm>
-            <a:off x="838200" y="942975"/>
+            <a:off x="838200" y="838200"/>
             <a:ext cx="381000" cy="47625"/>
           </a:xfrm>
           <a:prstGeom prst="roundRect">
@@ -3146,52 +3147,13 @@
       </p:sp>
       <p:sp>
         <p:nvSpPr>
-          <p:cNvPr id="3" name="TextBox 2"/>
-          <p:cNvSpPr txBox="1"/>
-          <p:nvPr/>
-        </p:nvSpPr>
-        <p:spPr>
-          <a:xfrm>
-            <a:off x="1371600" y="838200"/>
-            <a:ext cx="4712493" cy="333375"/>
-          </a:xfrm>
-          <a:prstGeom prst="rect">
-            <a:avLst/>
-          </a:prstGeom>
-          <a:noFill/>
-        </p:spPr>
-        <p:txBody>
-          <a:bodyPr wrap="none" lIns="0" rIns="0" tIns="0" bIns="0" anchor="t">
-            <a:noAutofit/>
-          </a:bodyPr>
-          <a:lstStyle/>
-          <a:p>
-            <a:pPr algn="l">
-              <a:lnSpc>
-                <a:spcPts val="0"/>
-              </a:lnSpc>
-            </a:pPr>
-            <a:r>
-              <a:rPr sz="1650" b="1" spc="264">
-                <a:solidFill>
-                  <a:srgbClr val="1657D0"/>
-                </a:solidFill>
-                <a:latin typeface="Figtree"/>
-              </a:rPr>
-              <a:t xml:space="preserve">CASO REAL · SETUP ARGENTINA</a:t>
-            </a:r>
-          </a:p>
-        </p:txBody>
-      </p:sp>
-      <p:sp>
-        <p:nvSpPr>
-          <p:cNvPr id="4" name="Rectangle 3"/>
+          <p:cNvPr id="3" name="Rectangle 2"/>
           <p:cNvSpPr/>
           <p:nvPr/>
         </p:nvSpPr>
         <p:spPr>
           <a:xfrm>
-            <a:off x="838200" y="6926764"/>
+            <a:off x="838200" y="7480256"/>
             <a:ext cx="2973139" cy="253746"/>
           </a:xfrm>
           <a:prstGeom prst="rect">
@@ -3229,13 +3191,13 @@
       </p:sp>
       <p:sp>
         <p:nvSpPr>
-          <p:cNvPr id="5" name="TextBox 4"/>
+          <p:cNvPr id="4" name="TextBox 3"/>
           <p:cNvSpPr txBox="1"/>
           <p:nvPr/>
         </p:nvSpPr>
         <p:spPr>
           <a:xfrm>
-            <a:off x="838200" y="4242941"/>
+            <a:off x="838200" y="4796432"/>
             <a:ext cx="9182100" cy="2951559"/>
           </a:xfrm>
           <a:prstGeom prst="rect">
@@ -3323,48 +3285,9 @@
           </a:p>
         </p:txBody>
       </p:sp>
-      <p:sp>
-        <p:nvSpPr>
-          <p:cNvPr id="6" name="TextBox 5"/>
-          <p:cNvSpPr txBox="1"/>
-          <p:nvPr/>
-        </p:nvSpPr>
-        <p:spPr>
-          <a:xfrm>
-            <a:off x="838200" y="7461200"/>
-            <a:ext cx="8153400" cy="1049833"/>
-          </a:xfrm>
-          <a:prstGeom prst="rect">
-            <a:avLst/>
-          </a:prstGeom>
-          <a:noFill/>
-        </p:spPr>
-        <p:txBody>
-          <a:bodyPr wrap="square" lIns="0" rIns="0" tIns="0" bIns="0" anchor="t">
-            <a:noAutofit/>
-          </a:bodyPr>
-          <a:lstStyle/>
-          <a:p>
-            <a:pPr algn="l">
-              <a:lnSpc>
-                <a:spcPts val="3833"/>
-              </a:lnSpc>
-            </a:pPr>
-            <a:r>
-              <a:rPr sz="2700" b="0">
-                <a:solidFill>
-                  <a:srgbClr val="46526B"/>
-                </a:solidFill>
-                <a:latin typeface="Figtree"/>
-              </a:rPr>
-              <a:t xml:space="preserve">Lo que pasó en el medio es lo que casi ninguna agencia cuenta.</a:t>
-            </a:r>
-          </a:p>
-        </p:txBody>
-      </p:sp>
       <p:pic>
         <p:nvPicPr>
-          <p:cNvPr id="7" name="Picture 6" descr="image.png"/>
+          <p:cNvPr id="5" name="Picture 4" descr="image.png"/>
           <p:cNvPicPr>
             <a:picLocks noChangeAspect="1"/>
           </p:cNvPicPr>
@@ -3388,7 +3311,7 @@
       </p:pic>
       <p:sp>
         <p:nvSpPr>
-          <p:cNvPr id="8" name="TextBox 7"/>
+          <p:cNvPr id="6" name="TextBox 5"/>
           <p:cNvSpPr txBox="1"/>
           <p:nvPr/>
         </p:nvSpPr>
@@ -3515,7 +3438,7 @@
         <p:spPr>
           <a:xfrm>
             <a:off x="1371600" y="838200"/>
-            <a:ext cx="2368004" cy="333375"/>
+            <a:ext cx="4712493" cy="333375"/>
           </a:xfrm>
           <a:prstGeom prst="rect">
             <a:avLst/>
@@ -3540,7 +3463,7 @@
                 </a:solidFill>
                 <a:latin typeface="Figtree"/>
               </a:rPr>
-              <a:t xml:space="preserve">CÓMO SIGUIÓ</a:t>
+              <a:t xml:space="preserve">CASO REAL · SETUP ARGENTINA</a:t>
             </a:r>
           </a:p>
         </p:txBody>
@@ -3553,7 +3476,7 @@
         </p:nvSpPr>
         <p:spPr>
           <a:xfrm>
-            <a:off x="838200" y="2896344"/>
+            <a:off x="838200" y="2719238"/>
             <a:ext cx="9182100" cy="1863625"/>
           </a:xfrm>
           <a:prstGeom prst="rect">
@@ -3608,7 +3531,7 @@
         </p:nvSpPr>
         <p:spPr>
           <a:xfrm>
-            <a:off x="838200" y="5179069"/>
+            <a:off x="838200" y="5001964"/>
             <a:ext cx="1257300" cy="619422"/>
           </a:xfrm>
           <a:prstGeom prst="rect">
@@ -3647,7 +3570,7 @@
         </p:nvSpPr>
         <p:spPr>
           <a:xfrm>
-            <a:off x="838200" y="6401097"/>
+            <a:off x="838200" y="6223992"/>
             <a:ext cx="1257300" cy="619422"/>
           </a:xfrm>
           <a:prstGeom prst="rect">
@@ -3686,7 +3609,7 @@
         </p:nvSpPr>
         <p:spPr>
           <a:xfrm>
-            <a:off x="838200" y="7623125"/>
+            <a:off x="838200" y="7800230"/>
             <a:ext cx="1257300" cy="619422"/>
           </a:xfrm>
           <a:prstGeom prst="rect">
@@ -3725,7 +3648,7 @@
         </p:nvSpPr>
         <p:spPr>
           <a:xfrm>
-            <a:off x="838200" y="8845153"/>
+            <a:off x="838200" y="9022258"/>
             <a:ext cx="1257300" cy="619422"/>
           </a:xfrm>
           <a:prstGeom prst="rect">
@@ -3764,7 +3687,7 @@
         </p:nvSpPr>
         <p:spPr>
           <a:xfrm>
-            <a:off x="1771650" y="5255269"/>
+            <a:off x="1771650" y="5078164"/>
             <a:ext cx="1757660" cy="514350"/>
           </a:xfrm>
           <a:prstGeom prst="rect">
@@ -3803,8 +3726,8 @@
         </p:nvSpPr>
         <p:spPr>
           <a:xfrm>
-            <a:off x="1771650" y="6477297"/>
-            <a:ext cx="5127426" cy="514350"/>
+            <a:off x="1771650" y="6300192"/>
+            <a:ext cx="4992141" cy="514350"/>
           </a:xfrm>
           <a:prstGeom prst="rect">
             <a:avLst/>
@@ -3829,7 +3752,7 @@
                 </a:solidFill>
                 <a:latin typeface="Figtree"/>
               </a:rPr>
-              <a:t xml:space="preserve">Una segunda web, con blog</a:t>
+              <a:t xml:space="preserve">El sitio completo, en inglés</a:t>
             </a:r>
           </a:p>
         </p:txBody>
@@ -3842,7 +3765,7 @@
         </p:nvSpPr>
         <p:spPr>
           <a:xfrm>
-            <a:off x="1771650" y="7699325"/>
+            <a:off x="1771650" y="7876430"/>
             <a:ext cx="3486298" cy="514350"/>
           </a:xfrm>
           <a:prstGeom prst="rect">
@@ -3881,8 +3804,8 @@
         </p:nvSpPr>
         <p:spPr>
           <a:xfrm>
-            <a:off x="1771650" y="8921353"/>
-            <a:ext cx="2712094" cy="514350"/>
+            <a:off x="1771650" y="9098458"/>
+            <a:ext cx="4487167" cy="514350"/>
           </a:xfrm>
           <a:prstGeom prst="rect">
             <a:avLst/>
@@ -3907,7 +3830,7 @@
                 </a:solidFill>
                 <a:latin typeface="Figtree"/>
               </a:rPr>
-              <a:t xml:space="preserve">Los anuncios</a:t>
+              <a:t xml:space="preserve">Los anuncios en Google</a:t>
             </a:r>
           </a:p>
         </p:txBody>
@@ -3920,7 +3843,7 @@
         </p:nvSpPr>
         <p:spPr>
           <a:xfrm>
-            <a:off x="1771650" y="5761136"/>
+            <a:off x="1771650" y="5584031"/>
             <a:ext cx="1243310" cy="430410"/>
           </a:xfrm>
           <a:prstGeom prst="rect">
@@ -3959,8 +3882,8 @@
         </p:nvSpPr>
         <p:spPr>
           <a:xfrm>
-            <a:off x="1771650" y="6983164"/>
-            <a:ext cx="4613076" cy="430410"/>
+            <a:off x="1771650" y="6806058"/>
+            <a:ext cx="7734300" cy="784621"/>
           </a:xfrm>
           <a:prstGeom prst="rect">
             <a:avLst/>
@@ -3985,7 +3908,7 @@
                 </a:solidFill>
                 <a:latin typeface="Figtree"/>
               </a:rPr>
-              <a:t xml:space="preserve">Para publicar sus propias notas</a:t>
+              <a:t xml:space="preserve">Para los clientes de afuera, con la versión en español a un click</a:t>
             </a:r>
           </a:p>
         </p:txBody>
@@ -3998,7 +3921,7 @@
         </p:nvSpPr>
         <p:spPr>
           <a:xfrm>
-            <a:off x="1771650" y="8205192"/>
+            <a:off x="1771650" y="8382297"/>
             <a:ext cx="5370760" cy="430410"/>
           </a:xfrm>
           <a:prstGeom prst="rect">
@@ -4037,8 +3960,8 @@
         </p:nvSpPr>
         <p:spPr>
           <a:xfrm>
-            <a:off x="1771650" y="9427219"/>
-            <a:ext cx="6481464" cy="430410"/>
+            <a:off x="1771650" y="9604325"/>
+            <a:ext cx="3972817" cy="430410"/>
           </a:xfrm>
           <a:prstGeom prst="rect">
             <a:avLst/>
@@ -4063,7 +3986,7 @@
                 </a:solidFill>
                 <a:latin typeface="Figtree"/>
               </a:rPr>
-              <a:t xml:space="preserve">Campañas de Google apuntadas a Estados Unidos</a:t>
+              <a:t xml:space="preserve">Apuntados a Estados Unidos</a:t>
             </a:r>
           </a:p>
         </p:txBody>
@@ -4149,6 +4072,585 @@
 </file>
 
 <file path=ppt/slides/slide3.xml><?xml version="1.0" encoding="utf-8"?>
+<p:sld xmlns:a="http://schemas.openxmlformats.org/drawingml/2006/main" xmlns:p="http://schemas.openxmlformats.org/presentationml/2006/main" xmlns:r="http://schemas.openxmlformats.org/officeDocument/2006/relationships">
+  <p:cSld>
+    <p:bg>
+      <p:bgPr>
+        <a:solidFill>
+          <a:srgbClr val="FFFFFF"/>
+        </a:solidFill>
+        <a:effectLst/>
+      </p:bgPr>
+    </p:bg>
+    <p:spTree>
+      <p:nvGrpSpPr>
+        <p:cNvPr id="1" name=""/>
+        <p:cNvGrpSpPr/>
+        <p:nvPr/>
+      </p:nvGrpSpPr>
+      <p:grpSpPr/>
+      <p:sp>
+        <p:nvSpPr>
+          <p:cNvPr id="2" name="Rounded Rectangle 1"/>
+          <p:cNvSpPr/>
+          <p:nvPr/>
+        </p:nvSpPr>
+        <p:spPr>
+          <a:xfrm>
+            <a:off x="838200" y="942975"/>
+            <a:ext cx="381000" cy="47625"/>
+          </a:xfrm>
+          <a:prstGeom prst="roundRect">
+            <a:avLst>
+              <a:gd name="adj" fmla="val 50000"/>
+            </a:avLst>
+          </a:prstGeom>
+          <a:solidFill>
+            <a:srgbClr val="00A8E8"/>
+          </a:solidFill>
+          <a:ln>
+            <a:noFill/>
+          </a:ln>
+          <a:effectLst/>
+        </p:spPr>
+        <p:style>
+          <a:lnRef idx="1">
+            <a:schemeClr val="accent1"/>
+          </a:lnRef>
+          <a:fillRef idx="3">
+            <a:schemeClr val="accent1"/>
+          </a:fillRef>
+          <a:effectRef idx="2">
+            <a:schemeClr val="accent1"/>
+          </a:effectRef>
+          <a:fontRef idx="minor">
+            <a:schemeClr val="lt1"/>
+          </a:fontRef>
+        </p:style>
+        <p:txBody>
+          <a:bodyPr rtlCol="0" anchor="ctr"/>
+          <a:lstStyle/>
+          <a:p>
+            <a:pPr algn="ctr"/>
+          </a:p>
+        </p:txBody>
+      </p:sp>
+      <p:sp>
+        <p:nvSpPr>
+          <p:cNvPr id="3" name="TextBox 2"/>
+          <p:cNvSpPr txBox="1"/>
+          <p:nvPr/>
+        </p:nvSpPr>
+        <p:spPr>
+          <a:xfrm>
+            <a:off x="1371600" y="838200"/>
+            <a:ext cx="3103959" cy="333375"/>
+          </a:xfrm>
+          <a:prstGeom prst="rect">
+            <a:avLst/>
+          </a:prstGeom>
+          <a:noFill/>
+        </p:spPr>
+        <p:txBody>
+          <a:bodyPr wrap="none" lIns="0" rIns="0" tIns="0" bIns="0" anchor="t">
+            <a:noAutofit/>
+          </a:bodyPr>
+          <a:lstStyle/>
+          <a:p>
+            <a:pPr algn="l">
+              <a:lnSpc>
+                <a:spcPts val="0"/>
+              </a:lnSpc>
+            </a:pPr>
+            <a:r>
+              <a:rPr sz="1650" b="1" spc="264">
+                <a:solidFill>
+                  <a:srgbClr val="1657D0"/>
+                </a:solidFill>
+                <a:latin typeface="Figtree"/>
+              </a:rPr>
+              <a:t xml:space="preserve">QUÉ CONSTRUIMOS</a:t>
+            </a:r>
+          </a:p>
+        </p:txBody>
+      </p:sp>
+      <p:sp>
+        <p:nvSpPr>
+          <p:cNvPr id="4" name="Rounded Rectangle 3"/>
+          <p:cNvSpPr/>
+          <p:nvPr/>
+        </p:nvSpPr>
+        <p:spPr>
+          <a:xfrm>
+            <a:off x="5638800" y="3498800"/>
+            <a:ext cx="495300" cy="38100"/>
+          </a:xfrm>
+          <a:prstGeom prst="roundRect">
+            <a:avLst>
+              <a:gd name="adj" fmla="val 50000"/>
+            </a:avLst>
+          </a:prstGeom>
+          <a:solidFill>
+            <a:srgbClr val="00A8E8"/>
+          </a:solidFill>
+          <a:ln>
+            <a:noFill/>
+          </a:ln>
+          <a:effectLst/>
+        </p:spPr>
+        <p:style>
+          <a:lnRef idx="1">
+            <a:schemeClr val="accent1"/>
+          </a:lnRef>
+          <a:fillRef idx="3">
+            <a:schemeClr val="accent1"/>
+          </a:fillRef>
+          <a:effectRef idx="2">
+            <a:schemeClr val="accent1"/>
+          </a:effectRef>
+          <a:fontRef idx="minor">
+            <a:schemeClr val="lt1"/>
+          </a:fontRef>
+        </p:style>
+        <p:txBody>
+          <a:bodyPr rtlCol="0" anchor="ctr"/>
+          <a:lstStyle/>
+          <a:p>
+            <a:pPr algn="ctr"/>
+          </a:p>
+        </p:txBody>
+      </p:sp>
+      <p:sp>
+        <p:nvSpPr>
+          <p:cNvPr id="5" name="Rounded Rectangle 4"/>
+          <p:cNvSpPr/>
+          <p:nvPr/>
+        </p:nvSpPr>
+        <p:spPr>
+          <a:xfrm>
+            <a:off x="5638800" y="5452318"/>
+            <a:ext cx="495300" cy="38100"/>
+          </a:xfrm>
+          <a:prstGeom prst="roundRect">
+            <a:avLst>
+              <a:gd name="adj" fmla="val 50000"/>
+            </a:avLst>
+          </a:prstGeom>
+          <a:solidFill>
+            <a:srgbClr val="00A8E8"/>
+          </a:solidFill>
+          <a:ln>
+            <a:noFill/>
+          </a:ln>
+          <a:effectLst/>
+        </p:spPr>
+        <p:style>
+          <a:lnRef idx="1">
+            <a:schemeClr val="accent1"/>
+          </a:lnRef>
+          <a:fillRef idx="3">
+            <a:schemeClr val="accent1"/>
+          </a:fillRef>
+          <a:effectRef idx="2">
+            <a:schemeClr val="accent1"/>
+          </a:effectRef>
+          <a:fontRef idx="minor">
+            <a:schemeClr val="lt1"/>
+          </a:fontRef>
+        </p:style>
+        <p:txBody>
+          <a:bodyPr rtlCol="0" anchor="ctr"/>
+          <a:lstStyle/>
+          <a:p>
+            <a:pPr algn="ctr"/>
+          </a:p>
+        </p:txBody>
+      </p:sp>
+      <p:sp>
+        <p:nvSpPr>
+          <p:cNvPr id="6" name="Rounded Rectangle 5"/>
+          <p:cNvSpPr/>
+          <p:nvPr/>
+        </p:nvSpPr>
+        <p:spPr>
+          <a:xfrm>
+            <a:off x="5638800" y="7729835"/>
+            <a:ext cx="495300" cy="38100"/>
+          </a:xfrm>
+          <a:prstGeom prst="roundRect">
+            <a:avLst>
+              <a:gd name="adj" fmla="val 50000"/>
+            </a:avLst>
+          </a:prstGeom>
+          <a:solidFill>
+            <a:srgbClr val="00A8E8"/>
+          </a:solidFill>
+          <a:ln>
+            <a:noFill/>
+          </a:ln>
+          <a:effectLst/>
+        </p:spPr>
+        <p:style>
+          <a:lnRef idx="1">
+            <a:schemeClr val="accent1"/>
+          </a:lnRef>
+          <a:fillRef idx="3">
+            <a:schemeClr val="accent1"/>
+          </a:fillRef>
+          <a:effectRef idx="2">
+            <a:schemeClr val="accent1"/>
+          </a:effectRef>
+          <a:fontRef idx="minor">
+            <a:schemeClr val="lt1"/>
+          </a:fontRef>
+        </p:style>
+        <p:txBody>
+          <a:bodyPr rtlCol="0" anchor="ctr"/>
+          <a:lstStyle/>
+          <a:p>
+            <a:pPr algn="ctr"/>
+          </a:p>
+        </p:txBody>
+      </p:sp>
+      <p:sp>
+        <p:nvSpPr>
+          <p:cNvPr id="7" name="TextBox 6"/>
+          <p:cNvSpPr txBox="1"/>
+          <p:nvPr/>
+        </p:nvSpPr>
+        <p:spPr>
+          <a:xfrm>
+            <a:off x="6324600" y="3327350"/>
+            <a:ext cx="3181350" cy="448121"/>
+          </a:xfrm>
+          <a:prstGeom prst="rect">
+            <a:avLst/>
+          </a:prstGeom>
+          <a:noFill/>
+        </p:spPr>
+        <p:txBody>
+          <a:bodyPr wrap="square" lIns="0" rIns="0" tIns="0" bIns="0" anchor="t">
+            <a:noAutofit/>
+          </a:bodyPr>
+          <a:lstStyle/>
+          <a:p>
+            <a:pPr algn="l">
+              <a:lnSpc>
+                <a:spcPts val="2929"/>
+              </a:lnSpc>
+            </a:pPr>
+            <a:r>
+              <a:rPr sz="2325" b="1">
+                <a:solidFill>
+                  <a:srgbClr val="0A1B33"/>
+                </a:solidFill>
+                <a:latin typeface="Figtree"/>
+              </a:rPr>
+              <a:t xml:space="preserve">En inglés por defecto</a:t>
+            </a:r>
+          </a:p>
+        </p:txBody>
+      </p:sp>
+      <p:sp>
+        <p:nvSpPr>
+          <p:cNvPr id="8" name="TextBox 7"/>
+          <p:cNvSpPr txBox="1"/>
+          <p:nvPr/>
+        </p:nvSpPr>
+        <p:spPr>
+          <a:xfrm>
+            <a:off x="6324600" y="5280868"/>
+            <a:ext cx="3181350" cy="448121"/>
+          </a:xfrm>
+          <a:prstGeom prst="rect">
+            <a:avLst/>
+          </a:prstGeom>
+          <a:noFill/>
+        </p:spPr>
+        <p:txBody>
+          <a:bodyPr wrap="square" lIns="0" rIns="0" tIns="0" bIns="0" anchor="t">
+            <a:noAutofit/>
+          </a:bodyPr>
+          <a:lstStyle/>
+          <a:p>
+            <a:pPr algn="l">
+              <a:lnSpc>
+                <a:spcPts val="2929"/>
+              </a:lnSpc>
+            </a:pPr>
+            <a:r>
+              <a:rPr sz="2325" b="1">
+                <a:solidFill>
+                  <a:srgbClr val="0A1B33"/>
+                </a:solidFill>
+                <a:latin typeface="Figtree"/>
+              </a:rPr>
+              <a:t xml:space="preserve">El español, a un toque</a:t>
+            </a:r>
+          </a:p>
+        </p:txBody>
+      </p:sp>
+      <p:sp>
+        <p:nvSpPr>
+          <p:cNvPr id="9" name="TextBox 8"/>
+          <p:cNvSpPr txBox="1"/>
+          <p:nvPr/>
+        </p:nvSpPr>
+        <p:spPr>
+          <a:xfrm>
+            <a:off x="6324600" y="7558385"/>
+            <a:ext cx="3181350" cy="820042"/>
+          </a:xfrm>
+          <a:prstGeom prst="rect">
+            <a:avLst/>
+          </a:prstGeom>
+          <a:noFill/>
+        </p:spPr>
+        <p:txBody>
+          <a:bodyPr wrap="square" lIns="0" rIns="0" tIns="0" bIns="0" anchor="t">
+            <a:noAutofit/>
+          </a:bodyPr>
+          <a:lstStyle/>
+          <a:p>
+            <a:pPr algn="l">
+              <a:lnSpc>
+                <a:spcPts val="2929"/>
+              </a:lnSpc>
+            </a:pPr>
+            <a:r>
+              <a:rPr sz="2325" b="1">
+                <a:solidFill>
+                  <a:srgbClr val="0A1B33"/>
+                </a:solidFill>
+                <a:latin typeface="Figtree"/>
+              </a:rPr>
+              <a:t xml:space="preserve">Un blog para sus propias notas</a:t>
+            </a:r>
+          </a:p>
+        </p:txBody>
+      </p:sp>
+      <p:sp>
+        <p:nvSpPr>
+          <p:cNvPr id="10" name="TextBox 9"/>
+          <p:cNvSpPr txBox="1"/>
+          <p:nvPr/>
+        </p:nvSpPr>
+        <p:spPr>
+          <a:xfrm>
+            <a:off x="6324600" y="3775471"/>
+            <a:ext cx="3181350" cy="1048196"/>
+          </a:xfrm>
+          <a:prstGeom prst="rect">
+            <a:avLst/>
+          </a:prstGeom>
+          <a:noFill/>
+        </p:spPr>
+        <p:txBody>
+          <a:bodyPr wrap="square" lIns="0" rIns="0" tIns="0" bIns="0" anchor="t">
+            <a:noAutofit/>
+          </a:bodyPr>
+          <a:lstStyle/>
+          <a:p>
+            <a:pPr algn="l">
+              <a:lnSpc>
+                <a:spcPts val="2551"/>
+              </a:lnSpc>
+            </a:pPr>
+            <a:r>
+              <a:rPr sz="2025" b="0">
+                <a:solidFill>
+                  <a:srgbClr val="46526B"/>
+                </a:solidFill>
+                <a:latin typeface="Figtree"/>
+              </a:rPr>
+              <a:t xml:space="preserve">Es un estudio de Buenos Aires que les vende a inversores del exterior.</a:t>
+            </a:r>
+          </a:p>
+        </p:txBody>
+      </p:sp>
+      <p:sp>
+        <p:nvSpPr>
+          <p:cNvPr id="11" name="TextBox 10"/>
+          <p:cNvSpPr txBox="1"/>
+          <p:nvPr/>
+        </p:nvSpPr>
+        <p:spPr>
+          <a:xfrm>
+            <a:off x="6324600" y="5728989"/>
+            <a:ext cx="3181350" cy="1372195"/>
+          </a:xfrm>
+          <a:prstGeom prst="rect">
+            <a:avLst/>
+          </a:prstGeom>
+          <a:noFill/>
+        </p:spPr>
+        <p:txBody>
+          <a:bodyPr wrap="square" lIns="0" rIns="0" tIns="0" bIns="0" anchor="t">
+            <a:noAutofit/>
+          </a:bodyPr>
+          <a:lstStyle/>
+          <a:p>
+            <a:pPr algn="l">
+              <a:lnSpc>
+                <a:spcPts val="2551"/>
+              </a:lnSpc>
+            </a:pPr>
+            <a:r>
+              <a:rPr sz="2025" b="0">
+                <a:solidFill>
+                  <a:srgbClr val="46526B"/>
+                </a:solidFill>
+                <a:latin typeface="Figtree"/>
+              </a:rPr>
+              <a:t xml:space="preserve">Y un aviso que se lo ofrece al que entra desde Argentina, sin cambiarle el idioma a la fuerza.</a:t>
+            </a:r>
+          </a:p>
+        </p:txBody>
+      </p:sp>
+      <p:sp>
+        <p:nvSpPr>
+          <p:cNvPr id="12" name="TextBox 11"/>
+          <p:cNvSpPr txBox="1"/>
+          <p:nvPr/>
+        </p:nvSpPr>
+        <p:spPr>
+          <a:xfrm>
+            <a:off x="6324600" y="8378428"/>
+            <a:ext cx="3181350" cy="1048196"/>
+          </a:xfrm>
+          <a:prstGeom prst="rect">
+            <a:avLst/>
+          </a:prstGeom>
+          <a:noFill/>
+        </p:spPr>
+        <p:txBody>
+          <a:bodyPr wrap="square" lIns="0" rIns="0" tIns="0" bIns="0" anchor="t">
+            <a:noAutofit/>
+          </a:bodyPr>
+          <a:lstStyle/>
+          <a:p>
+            <a:pPr algn="l">
+              <a:lnSpc>
+                <a:spcPts val="2551"/>
+              </a:lnSpc>
+            </a:pPr>
+            <a:r>
+              <a:rPr sz="2025" b="0">
+                <a:solidFill>
+                  <a:srgbClr val="46526B"/>
+                </a:solidFill>
+                <a:latin typeface="Figtree"/>
+              </a:rPr>
+              <a:t xml:space="preserve">Las escribe él; nosotros armamos el lugar para publicarlas.</a:t>
+            </a:r>
+          </a:p>
+        </p:txBody>
+      </p:sp>
+      <p:pic>
+        <p:nvPicPr>
+          <p:cNvPr id="13" name="Picture 12" descr="image.png"/>
+          <p:cNvPicPr>
+            <a:picLocks noChangeAspect="1"/>
+          </p:cNvPicPr>
+          <p:nvPr/>
+        </p:nvPicPr>
+        <p:blipFill>
+          <a:blip r:embed="rId2"/>
+          <a:stretch>
+            <a:fillRect/>
+          </a:stretch>
+        </p:blipFill>
+        <p:spPr>
+          <a:xfrm>
+            <a:off x="674515" y="1954124"/>
+            <a:ext cx="4632668" cy="8769525"/>
+          </a:xfrm>
+          <a:prstGeom prst="rect">
+            <a:avLst/>
+          </a:prstGeom>
+        </p:spPr>
+      </p:pic>
+      <p:pic>
+        <p:nvPicPr>
+          <p:cNvPr id="14" name="Picture 13" descr="image.png"/>
+          <p:cNvPicPr>
+            <a:picLocks noChangeAspect="1"/>
+          </p:cNvPicPr>
+          <p:nvPr/>
+        </p:nvPicPr>
+        <p:blipFill>
+          <a:blip r:embed="rId3"/>
+          <a:stretch>
+            <a:fillRect/>
+          </a:stretch>
+        </p:blipFill>
+        <p:spPr>
+          <a:xfrm>
+            <a:off x="838200" y="11582400"/>
+            <a:ext cx="438150" cy="438150"/>
+          </a:xfrm>
+          <a:prstGeom prst="rect">
+            <a:avLst/>
+          </a:prstGeom>
+        </p:spPr>
+      </p:pic>
+      <p:sp>
+        <p:nvSpPr>
+          <p:cNvPr id="15" name="TextBox 14"/>
+          <p:cNvSpPr txBox="1"/>
+          <p:nvPr/>
+        </p:nvSpPr>
+        <p:spPr>
+          <a:xfrm>
+            <a:off x="7955756" y="11663362"/>
+            <a:ext cx="2064543" cy="352425"/>
+          </a:xfrm>
+          <a:prstGeom prst="rect">
+            <a:avLst/>
+          </a:prstGeom>
+          <a:noFill/>
+        </p:spPr>
+        <p:txBody>
+          <a:bodyPr wrap="none" lIns="0" rIns="0" tIns="0" bIns="0" anchor="t">
+            <a:noAutofit/>
+          </a:bodyPr>
+          <a:lstStyle/>
+          <a:p>
+            <a:pPr algn="l">
+              <a:lnSpc>
+                <a:spcPts val="0"/>
+              </a:lnSpc>
+            </a:pPr>
+            <a:r>
+              <a:rPr sz="1800" b="1" spc="252">
+                <a:solidFill>
+                  <a:srgbClr val="1657D0"/>
+                </a:solidFill>
+                <a:latin typeface="Figtree"/>
+              </a:rPr>
+              <a:t xml:space="preserve">DESLIZÁ </a:t>
+            </a:r>
+            <a:r>
+              <a:rPr sz="1800" b="1" spc="252">
+                <a:solidFill>
+                  <a:srgbClr val="1657D0"/>
+                </a:solidFill>
+                <a:latin typeface="Figtree"/>
+              </a:rPr>
+              <a:t xml:space="preserve"> →</a:t>
+            </a:r>
+          </a:p>
+        </p:txBody>
+      </p:sp>
+    </p:spTree>
+  </p:cSld>
+  <p:clrMapOvr>
+    <a:masterClrMapping/>
+  </p:clrMapOvr>
+</p:sld>
+</file>
+
+<file path=ppt/slides/slide4.xml><?xml version="1.0" encoding="utf-8"?>
 <p:sld xmlns:a="http://schemas.openxmlformats.org/drawingml/2006/main" xmlns:p="http://schemas.openxmlformats.org/presentationml/2006/main" xmlns:r="http://schemas.openxmlformats.org/officeDocument/2006/relationships">
   <p:cSld>
     <p:bg>
@@ -4220,7 +4722,7 @@
         </p:nvSpPr>
         <p:spPr>
           <a:xfrm>
-            <a:off x="838200" y="3845123"/>
+            <a:off x="838200" y="4503390"/>
             <a:ext cx="9182100" cy="2232719"/>
           </a:xfrm>
           <a:prstGeom prst="rect">
@@ -4294,52 +4796,13 @@
       </p:sp>
       <p:sp>
         <p:nvSpPr>
-          <p:cNvPr id="4" name="TextBox 3"/>
-          <p:cNvSpPr txBox="1"/>
-          <p:nvPr/>
-        </p:nvSpPr>
-        <p:spPr>
-          <a:xfrm>
-            <a:off x="838200" y="6344542"/>
-            <a:ext cx="8153400" cy="1049833"/>
-          </a:xfrm>
-          <a:prstGeom prst="rect">
-            <a:avLst/>
-          </a:prstGeom>
-          <a:noFill/>
-        </p:spPr>
-        <p:txBody>
-          <a:bodyPr wrap="square" lIns="0" rIns="0" tIns="0" bIns="0" anchor="t">
-            <a:noAutofit/>
-          </a:bodyPr>
-          <a:lstStyle/>
-          <a:p>
-            <a:pPr algn="l">
-              <a:lnSpc>
-                <a:spcPts val="3833"/>
-              </a:lnSpc>
-            </a:pPr>
-            <a:r>
-              <a:rPr sz="2700" b="0">
-                <a:solidFill>
-                  <a:srgbClr val="B9CFE8"/>
-                </a:solidFill>
-                <a:latin typeface="Figtree"/>
-              </a:rPr>
-              <a:t xml:space="preserve">Empieza ahí. Una web nuestra no es un archivo que te mandamos y chau.</a:t>
-            </a:r>
-          </a:p>
-        </p:txBody>
-      </p:sp>
-      <p:sp>
-        <p:nvSpPr>
-          <p:cNvPr id="5" name="Rounded Rectangle 4"/>
+          <p:cNvPr id="4" name="Rounded Rectangle 3"/>
           <p:cNvSpPr/>
           <p:nvPr/>
         </p:nvSpPr>
         <p:spPr>
           <a:xfrm>
-            <a:off x="838200" y="7737276"/>
+            <a:off x="838200" y="7079009"/>
             <a:ext cx="5870376" cy="885825"/>
           </a:xfrm>
           <a:prstGeom prst="roundRect">
@@ -4379,13 +4842,13 @@
       </p:sp>
       <p:sp>
         <p:nvSpPr>
-          <p:cNvPr id="6" name="TextBox 5"/>
+          <p:cNvPr id="5" name="TextBox 4"/>
           <p:cNvSpPr txBox="1"/>
           <p:nvPr/>
         </p:nvSpPr>
         <p:spPr>
           <a:xfrm>
-            <a:off x="1257300" y="8003976"/>
+            <a:off x="1257300" y="7345709"/>
             <a:ext cx="5194101" cy="428625"/>
           </a:xfrm>
           <a:prstGeom prst="rect">
@@ -4418,7 +4881,7 @@
       </p:sp>
       <p:pic>
         <p:nvPicPr>
-          <p:cNvPr id="7" name="Picture 6" descr="image.png"/>
+          <p:cNvPr id="6" name="Picture 5" descr="image.png"/>
           <p:cNvPicPr>
             <a:picLocks noChangeAspect="1"/>
           </p:cNvPicPr>

</xml_diff>

<commit_message>
Setup Argentina rehecho: por que un estudio argentino tiene la web en ingles
El gancho de julio/septiembre contaba fechas y no una idea. Ahora arranca
con la foto de Agustin (publicada en /about/ de su sitio) y la pregunta, y
la respuesta es la estrategia: sus clientes estan afuera, por eso el
ingles por defecto y los anuncios a Estados Unidos. Sale la cronologia.

Co-Authored-By: Claude Opus 5 <noreply@anthropic.com>
</commit_message>
<xml_diff>
--- a/contenido/carruseles/06-setup-argentina/editable-canva.pptx
+++ b/contenido/carruseles/06-setup-argentina/editable-canva.pptx
@@ -3099,9 +3099,33 @@
         <p:nvPr/>
       </p:nvGrpSpPr>
       <p:grpSpPr/>
-      <p:sp>
-        <p:nvSpPr>
-          <p:cNvPr id="2" name="Rounded Rectangle 1"/>
+      <p:pic>
+        <p:nvPicPr>
+          <p:cNvPr id="2" name="Picture 1" descr="image.jpg"/>
+          <p:cNvPicPr>
+            <a:picLocks noChangeAspect="1"/>
+          </p:cNvPicPr>
+          <p:nvPr/>
+        </p:nvPicPr>
+        <p:blipFill>
+          <a:blip r:embed="rId2"/>
+          <a:stretch>
+            <a:fillRect/>
+          </a:stretch>
+        </p:blipFill>
+        <p:spPr>
+          <a:xfrm>
+            <a:off x="0" y="0"/>
+            <a:ext cx="10287000" cy="12858750"/>
+          </a:xfrm>
+          <a:prstGeom prst="rect">
+            <a:avLst/>
+          </a:prstGeom>
+        </p:spPr>
+      </p:pic>
+      <p:sp>
+        <p:nvSpPr>
+          <p:cNvPr id="3" name="Rounded Rectangle 2"/>
           <p:cNvSpPr/>
           <p:nvPr/>
         </p:nvSpPr>
@@ -3147,20 +3171,20 @@
       </p:sp>
       <p:sp>
         <p:nvSpPr>
-          <p:cNvPr id="3" name="Rectangle 2"/>
+          <p:cNvPr id="4" name="Rectangle 3"/>
           <p:cNvSpPr/>
           <p:nvPr/>
         </p:nvSpPr>
         <p:spPr>
           <a:xfrm>
-            <a:off x="838200" y="7480256"/>
-            <a:ext cx="2973139" cy="253746"/>
+            <a:off x="838200" y="7336976"/>
+            <a:ext cx="3318569" cy="315468"/>
           </a:xfrm>
           <a:prstGeom prst="rect">
             <a:avLst/>
           </a:prstGeom>
           <a:solidFill>
-            <a:srgbClr val="A8E1F8"/>
+            <a:srgbClr val="73CFF2"/>
           </a:solidFill>
           <a:ln>
             <a:noFill/>
@@ -3191,14 +3215,14 @@
       </p:sp>
       <p:sp>
         <p:nvSpPr>
-          <p:cNvPr id="4" name="TextBox 3"/>
+          <p:cNvPr id="5" name="TextBox 4"/>
           <p:cNvSpPr txBox="1"/>
           <p:nvPr/>
         </p:nvSpPr>
         <p:spPr>
           <a:xfrm>
-            <a:off x="838200" y="4796432"/>
-            <a:ext cx="9182100" cy="2951559"/>
+            <a:off x="838200" y="4893468"/>
+            <a:ext cx="9182100" cy="2757338"/>
           </a:xfrm>
           <a:prstGeom prst="rect">
             <a:avLst/>
@@ -3213,88 +3237,72 @@
           <a:p>
             <a:pPr algn="l">
               <a:lnSpc>
-                <a:spcPts val="5661"/>
+                <a:spcPts val="7038"/>
               </a:lnSpc>
             </a:pPr>
             <a:r>
-              <a:rPr sz="5550" b="1" spc="-166">
+              <a:rPr sz="6900" b="1" spc="-206">
                 <a:solidFill>
-                  <a:srgbClr val="0A1B33"/>
+                  <a:srgbClr val="FFFFFF"/>
                 </a:solidFill>
                 <a:latin typeface="Bricolage Grotesque"/>
               </a:rPr>
-              <a:t xml:space="preserve">Le entregamos</a:t>
+              <a:t xml:space="preserve">¿Por qué Agustín</a:t>
             </a:r>
           </a:p>
           <a:p>
             <a:pPr algn="l">
               <a:lnSpc>
-                <a:spcPts val="5661"/>
+                <a:spcPts val="7038"/>
               </a:lnSpc>
             </a:pPr>
             <a:r>
-              <a:rPr sz="5550" b="1" spc="-166">
+              <a:rPr sz="6900" b="1" spc="-206">
                 <a:solidFill>
-                  <a:srgbClr val="0A1B33"/>
+                  <a:srgbClr val="FFFFFF"/>
                 </a:solidFill>
                 <a:latin typeface="Bricolage Grotesque"/>
               </a:rPr>
-              <a:t xml:space="preserve">la web en julio.</a:t>
+              <a:t xml:space="preserve">tiene la web</a:t>
             </a:r>
           </a:p>
           <a:p>
             <a:pPr algn="l">
               <a:lnSpc>
-                <a:spcPts val="5661"/>
+                <a:spcPts val="7038"/>
               </a:lnSpc>
             </a:pPr>
             <a:r>
-              <a:rPr sz="5550" b="1" spc="-166">
+              <a:rPr sz="6900" b="1" spc="-206">
                 <a:solidFill>
-                  <a:srgbClr val="0A1B33"/>
+                  <a:srgbClr val="FFFFFF"/>
                 </a:solidFill>
                 <a:latin typeface="Bricolage Grotesque"/>
               </a:rPr>
-              <a:t xml:space="preserve">En septiembre</a:t>
-            </a:r>
-          </a:p>
-          <a:p>
-            <a:pPr algn="l">
-              <a:lnSpc>
-                <a:spcPts val="5661"/>
-              </a:lnSpc>
-            </a:pPr>
-            <a:r>
-              <a:rPr sz="5550" b="1" spc="-166">
+              <a:t xml:space="preserve">en inglés</a:t>
+            </a:r>
+            <a:r>
+              <a:rPr sz="6900" b="1" spc="-206">
                 <a:solidFill>
-                  <a:srgbClr val="0A1B33"/>
+                  <a:srgbClr val="FFFFFF"/>
                 </a:solidFill>
                 <a:latin typeface="Bricolage Grotesque"/>
               </a:rPr>
-              <a:t xml:space="preserve">seguimos</a:t>
-            </a:r>
-            <a:r>
-              <a:rPr sz="5550" b="1" spc="-166">
-                <a:solidFill>
-                  <a:srgbClr val="0A1B33"/>
-                </a:solidFill>
-                <a:latin typeface="Bricolage Grotesque"/>
-              </a:rPr>
-              <a:t xml:space="preserve">.</a:t>
+              <a:t xml:space="preserve">?</a:t>
             </a:r>
           </a:p>
         </p:txBody>
       </p:sp>
       <p:pic>
         <p:nvPicPr>
-          <p:cNvPr id="5" name="Picture 4" descr="image.png"/>
+          <p:cNvPr id="6" name="Picture 5" descr="image.png"/>
           <p:cNvPicPr>
             <a:picLocks noChangeAspect="1"/>
           </p:cNvPicPr>
           <p:nvPr/>
         </p:nvPicPr>
         <p:blipFill>
-          <a:blip r:embed="rId2"/>
+          <a:blip r:embed="rId3"/>
           <a:stretch>
             <a:fillRect/>
           </a:stretch>
@@ -3311,7 +3319,7 @@
       </p:pic>
       <p:sp>
         <p:nvSpPr>
-          <p:cNvPr id="6" name="TextBox 5"/>
+          <p:cNvPr id="7" name="TextBox 6"/>
           <p:cNvSpPr txBox="1"/>
           <p:nvPr/>
         </p:nvSpPr>
@@ -3339,7 +3347,7 @@
             <a:r>
               <a:rPr sz="1800" b="1" spc="252">
                 <a:solidFill>
-                  <a:srgbClr val="1657D0"/>
+                  <a:srgbClr val="8FD8F5"/>
                 </a:solidFill>
                 <a:latin typeface="Figtree"/>
               </a:rPr>
@@ -3348,7 +3356,7 @@
             <a:r>
               <a:rPr sz="1800" b="1" spc="252">
                 <a:solidFill>
-                  <a:srgbClr val="1657D0"/>
+                  <a:srgbClr val="8FD8F5"/>
                 </a:solidFill>
                 <a:latin typeface="Figtree"/>
               </a:rPr>
@@ -3371,7 +3379,7 @@
     <p:bg>
       <p:bgPr>
         <a:solidFill>
-          <a:srgbClr val="F2F6FC"/>
+          <a:srgbClr val="003878"/>
         </a:solidFill>
         <a:effectLst/>
       </p:bgPr>
@@ -3459,7 +3467,7 @@
             <a:r>
               <a:rPr sz="1650" b="1" spc="264">
                 <a:solidFill>
-                  <a:srgbClr val="1657D0"/>
+                  <a:srgbClr val="8FD8F5"/>
                 </a:solidFill>
                 <a:latin typeface="Figtree"/>
               </a:rPr>
@@ -3476,8 +3484,8 @@
         </p:nvSpPr>
         <p:spPr>
           <a:xfrm>
-            <a:off x="838200" y="2719238"/>
-            <a:ext cx="9182100" cy="1863625"/>
+            <a:off x="838200" y="4096642"/>
+            <a:ext cx="9182100" cy="2757338"/>
           </a:xfrm>
           <a:prstGeom prst="rect">
             <a:avLst/>
@@ -3498,11 +3506,11 @@
             <a:r>
               <a:rPr sz="6900" b="1" spc="-206">
                 <a:solidFill>
-                  <a:srgbClr val="0A1B33"/>
+                  <a:srgbClr val="FFFFFF"/>
                 </a:solidFill>
                 <a:latin typeface="Bricolage Grotesque"/>
               </a:rPr>
-              <a:t xml:space="preserve">Una cosa</a:t>
+              <a:t xml:space="preserve">Porque sus</a:t>
             </a:r>
           </a:p>
           <a:p>
@@ -3514,11 +3522,36 @@
             <a:r>
               <a:rPr sz="6900" b="1" spc="-206">
                 <a:solidFill>
-                  <a:srgbClr val="0A1B33"/>
+                  <a:srgbClr val="FFFFFF"/>
                 </a:solidFill>
                 <a:latin typeface="Bricolage Grotesque"/>
               </a:rPr>
-              <a:t xml:space="preserve">llevó a la otra.</a:t>
+              <a:t xml:space="preserve">clientes están</a:t>
+            </a:r>
+          </a:p>
+          <a:p>
+            <a:pPr algn="l">
+              <a:lnSpc>
+                <a:spcPts val="7038"/>
+              </a:lnSpc>
+            </a:pPr>
+            <a:r>
+              <a:rPr sz="6900" b="1" spc="-206">
+                <a:solidFill>
+                  <a:srgbClr val="63C8F2"/>
+                </a:solidFill>
+                <a:latin typeface="Bricolage Grotesque"/>
+              </a:rPr>
+              <a:t xml:space="preserve">afuera</a:t>
+            </a:r>
+            <a:r>
+              <a:rPr sz="6900" b="1" spc="-206">
+                <a:solidFill>
+                  <a:srgbClr val="FFFFFF"/>
+                </a:solidFill>
+                <a:latin typeface="Bricolage Grotesque"/>
+              </a:rPr>
+              <a:t xml:space="preserve">.</a:t>
             </a:r>
           </a:p>
         </p:txBody>
@@ -3531,8 +3564,8 @@
         </p:nvSpPr>
         <p:spPr>
           <a:xfrm>
-            <a:off x="838200" y="5001964"/>
-            <a:ext cx="1257300" cy="619422"/>
+            <a:off x="838200" y="7120681"/>
+            <a:ext cx="8153400" cy="1536650"/>
           </a:xfrm>
           <a:prstGeom prst="rect">
             <a:avLst/>
@@ -3540,460 +3573,31 @@
           <a:noFill/>
         </p:spPr>
         <p:txBody>
-          <a:bodyPr wrap="none" lIns="0" rIns="0" tIns="0" bIns="0" anchor="t">
+          <a:bodyPr wrap="square" lIns="0" rIns="0" tIns="0" bIns="0" anchor="t">
             <a:noAutofit/>
           </a:bodyPr>
           <a:lstStyle/>
           <a:p>
             <a:pPr algn="l">
               <a:lnSpc>
-                <a:spcPts val="4278"/>
+                <a:spcPts val="3833"/>
               </a:lnSpc>
             </a:pPr>
             <a:r>
-              <a:rPr sz="3450" b="1" spc="-69">
+              <a:rPr sz="2700" b="0">
                 <a:solidFill>
-                  <a:srgbClr val="1657D0"/>
-                </a:solidFill>
-                <a:latin typeface="Bricolage Grotesque"/>
-              </a:rPr>
-              <a:t xml:space="preserve">01</a:t>
-            </a:r>
-          </a:p>
-        </p:txBody>
-      </p:sp>
-      <p:sp>
-        <p:nvSpPr>
-          <p:cNvPr id="6" name="TextBox 5"/>
-          <p:cNvSpPr txBox="1"/>
-          <p:nvPr/>
-        </p:nvSpPr>
-        <p:spPr>
-          <a:xfrm>
-            <a:off x="838200" y="6223992"/>
-            <a:ext cx="1257300" cy="619422"/>
-          </a:xfrm>
-          <a:prstGeom prst="rect">
-            <a:avLst/>
-          </a:prstGeom>
-          <a:noFill/>
-        </p:spPr>
-        <p:txBody>
-          <a:bodyPr wrap="none" lIns="0" rIns="0" tIns="0" bIns="0" anchor="t">
-            <a:noAutofit/>
-          </a:bodyPr>
-          <a:lstStyle/>
-          <a:p>
-            <a:pPr algn="l">
-              <a:lnSpc>
-                <a:spcPts val="4278"/>
-              </a:lnSpc>
-            </a:pPr>
-            <a:r>
-              <a:rPr sz="3450" b="1" spc="-69">
-                <a:solidFill>
-                  <a:srgbClr val="1657D0"/>
-                </a:solidFill>
-                <a:latin typeface="Bricolage Grotesque"/>
-              </a:rPr>
-              <a:t xml:space="preserve">02</a:t>
-            </a:r>
-          </a:p>
-        </p:txBody>
-      </p:sp>
-      <p:sp>
-        <p:nvSpPr>
-          <p:cNvPr id="7" name="TextBox 6"/>
-          <p:cNvSpPr txBox="1"/>
-          <p:nvPr/>
-        </p:nvSpPr>
-        <p:spPr>
-          <a:xfrm>
-            <a:off x="838200" y="7800230"/>
-            <a:ext cx="1257300" cy="619422"/>
-          </a:xfrm>
-          <a:prstGeom prst="rect">
-            <a:avLst/>
-          </a:prstGeom>
-          <a:noFill/>
-        </p:spPr>
-        <p:txBody>
-          <a:bodyPr wrap="none" lIns="0" rIns="0" tIns="0" bIns="0" anchor="t">
-            <a:noAutofit/>
-          </a:bodyPr>
-          <a:lstStyle/>
-          <a:p>
-            <a:pPr algn="l">
-              <a:lnSpc>
-                <a:spcPts val="4278"/>
-              </a:lnSpc>
-            </a:pPr>
-            <a:r>
-              <a:rPr sz="3450" b="1" spc="-69">
-                <a:solidFill>
-                  <a:srgbClr val="1657D0"/>
-                </a:solidFill>
-                <a:latin typeface="Bricolage Grotesque"/>
-              </a:rPr>
-              <a:t xml:space="preserve">03</a:t>
-            </a:r>
-          </a:p>
-        </p:txBody>
-      </p:sp>
-      <p:sp>
-        <p:nvSpPr>
-          <p:cNvPr id="8" name="TextBox 7"/>
-          <p:cNvSpPr txBox="1"/>
-          <p:nvPr/>
-        </p:nvSpPr>
-        <p:spPr>
-          <a:xfrm>
-            <a:off x="838200" y="9022258"/>
-            <a:ext cx="1257300" cy="619422"/>
-          </a:xfrm>
-          <a:prstGeom prst="rect">
-            <a:avLst/>
-          </a:prstGeom>
-          <a:noFill/>
-        </p:spPr>
-        <p:txBody>
-          <a:bodyPr wrap="none" lIns="0" rIns="0" tIns="0" bIns="0" anchor="t">
-            <a:noAutofit/>
-          </a:bodyPr>
-          <a:lstStyle/>
-          <a:p>
-            <a:pPr algn="l">
-              <a:lnSpc>
-                <a:spcPts val="4278"/>
-              </a:lnSpc>
-            </a:pPr>
-            <a:r>
-              <a:rPr sz="3450" b="1" spc="-69">
-                <a:solidFill>
-                  <a:srgbClr val="1657D0"/>
-                </a:solidFill>
-                <a:latin typeface="Bricolage Grotesque"/>
-              </a:rPr>
-              <a:t xml:space="preserve">04</a:t>
-            </a:r>
-          </a:p>
-        </p:txBody>
-      </p:sp>
-      <p:sp>
-        <p:nvSpPr>
-          <p:cNvPr id="9" name="TextBox 8"/>
-          <p:cNvSpPr txBox="1"/>
-          <p:nvPr/>
-        </p:nvSpPr>
-        <p:spPr>
-          <a:xfrm>
-            <a:off x="1771650" y="5078164"/>
-            <a:ext cx="1757660" cy="514350"/>
-          </a:xfrm>
-          <a:prstGeom prst="rect">
-            <a:avLst/>
-          </a:prstGeom>
-          <a:noFill/>
-        </p:spPr>
-        <p:txBody>
-          <a:bodyPr wrap="none" lIns="0" rIns="0" tIns="0" bIns="0" anchor="t">
-            <a:noAutofit/>
-          </a:bodyPr>
-          <a:lstStyle/>
-          <a:p>
-            <a:pPr algn="l">
-              <a:lnSpc>
-                <a:spcPts val="3533"/>
-              </a:lnSpc>
-            </a:pPr>
-            <a:r>
-              <a:rPr sz="2850" b="1">
-                <a:solidFill>
-                  <a:srgbClr val="0A1B33"/>
+                  <a:srgbClr val="B9CFE8"/>
                 </a:solidFill>
                 <a:latin typeface="Figtree"/>
               </a:rPr>
-              <a:t xml:space="preserve">La web</a:t>
-            </a:r>
-          </a:p>
-        </p:txBody>
-      </p:sp>
-      <p:sp>
-        <p:nvSpPr>
-          <p:cNvPr id="10" name="TextBox 9"/>
-          <p:cNvSpPr txBox="1"/>
-          <p:nvPr/>
-        </p:nvSpPr>
-        <p:spPr>
-          <a:xfrm>
-            <a:off x="1771650" y="6300192"/>
-            <a:ext cx="4992141" cy="514350"/>
-          </a:xfrm>
-          <a:prstGeom prst="rect">
-            <a:avLst/>
-          </a:prstGeom>
-          <a:noFill/>
-        </p:spPr>
-        <p:txBody>
-          <a:bodyPr wrap="none" lIns="0" rIns="0" tIns="0" bIns="0" anchor="t">
-            <a:noAutofit/>
-          </a:bodyPr>
-          <a:lstStyle/>
-          <a:p>
-            <a:pPr algn="l">
-              <a:lnSpc>
-                <a:spcPts val="3533"/>
-              </a:lnSpc>
-            </a:pPr>
-            <a:r>
-              <a:rPr sz="2850" b="1">
-                <a:solidFill>
-                  <a:srgbClr val="0A1B33"/>
-                </a:solidFill>
-                <a:latin typeface="Figtree"/>
-              </a:rPr>
-              <a:t xml:space="preserve">El sitio completo, en inglés</a:t>
-            </a:r>
-          </a:p>
-        </p:txBody>
-      </p:sp>
-      <p:sp>
-        <p:nvSpPr>
-          <p:cNvPr id="11" name="TextBox 10"/>
-          <p:cNvSpPr txBox="1"/>
-          <p:nvPr/>
-        </p:nvSpPr>
-        <p:spPr>
-          <a:xfrm>
-            <a:off x="1771650" y="7876430"/>
-            <a:ext cx="3486298" cy="514350"/>
-          </a:xfrm>
-          <a:prstGeom prst="rect">
-            <a:avLst/>
-          </a:prstGeom>
-          <a:noFill/>
-        </p:spPr>
-        <p:txBody>
-          <a:bodyPr wrap="none" lIns="0" rIns="0" tIns="0" bIns="0" anchor="t">
-            <a:noAutofit/>
-          </a:bodyPr>
-          <a:lstStyle/>
-          <a:p>
-            <a:pPr algn="l">
-              <a:lnSpc>
-                <a:spcPts val="3533"/>
-              </a:lnSpc>
-            </a:pPr>
-            <a:r>
-              <a:rPr sz="2850" b="1">
-                <a:solidFill>
-                  <a:srgbClr val="0A1B33"/>
-                </a:solidFill>
-                <a:latin typeface="Figtree"/>
-              </a:rPr>
-              <a:t xml:space="preserve">El mantenimiento</a:t>
-            </a:r>
-          </a:p>
-        </p:txBody>
-      </p:sp>
-      <p:sp>
-        <p:nvSpPr>
-          <p:cNvPr id="12" name="TextBox 11"/>
-          <p:cNvSpPr txBox="1"/>
-          <p:nvPr/>
-        </p:nvSpPr>
-        <p:spPr>
-          <a:xfrm>
-            <a:off x="1771650" y="9098458"/>
-            <a:ext cx="4487167" cy="514350"/>
-          </a:xfrm>
-          <a:prstGeom prst="rect">
-            <a:avLst/>
-          </a:prstGeom>
-          <a:noFill/>
-        </p:spPr>
-        <p:txBody>
-          <a:bodyPr wrap="none" lIns="0" rIns="0" tIns="0" bIns="0" anchor="t">
-            <a:noAutofit/>
-          </a:bodyPr>
-          <a:lstStyle/>
-          <a:p>
-            <a:pPr algn="l">
-              <a:lnSpc>
-                <a:spcPts val="3533"/>
-              </a:lnSpc>
-            </a:pPr>
-            <a:r>
-              <a:rPr sz="2850" b="1">
-                <a:solidFill>
-                  <a:srgbClr val="0A1B33"/>
-                </a:solidFill>
-                <a:latin typeface="Figtree"/>
-              </a:rPr>
-              <a:t xml:space="preserve">Los anuncios en Google</a:t>
-            </a:r>
-          </a:p>
-        </p:txBody>
-      </p:sp>
-      <p:sp>
-        <p:nvSpPr>
-          <p:cNvPr id="13" name="TextBox 12"/>
-          <p:cNvSpPr txBox="1"/>
-          <p:nvPr/>
-        </p:nvSpPr>
-        <p:spPr>
-          <a:xfrm>
-            <a:off x="1771650" y="5584031"/>
-            <a:ext cx="1243310" cy="430410"/>
-          </a:xfrm>
-          <a:prstGeom prst="rect">
-            <a:avLst/>
-          </a:prstGeom>
-          <a:noFill/>
-        </p:spPr>
-        <p:txBody>
-          <a:bodyPr wrap="square" lIns="0" rIns="0" tIns="0" bIns="0" anchor="t">
-            <a:noAutofit/>
-          </a:bodyPr>
-          <a:lstStyle/>
-          <a:p>
-            <a:pPr algn="l">
-              <a:lnSpc>
-                <a:spcPts val="2790"/>
-              </a:lnSpc>
-            </a:pPr>
-            <a:r>
-              <a:rPr sz="2250" b="0">
-                <a:solidFill>
-                  <a:srgbClr val="46526B"/>
-                </a:solidFill>
-                <a:latin typeface="Figtree"/>
-              </a:rPr>
-              <a:t xml:space="preserve">Julio</a:t>
-            </a:r>
-          </a:p>
-        </p:txBody>
-      </p:sp>
-      <p:sp>
-        <p:nvSpPr>
-          <p:cNvPr id="14" name="TextBox 13"/>
-          <p:cNvSpPr txBox="1"/>
-          <p:nvPr/>
-        </p:nvSpPr>
-        <p:spPr>
-          <a:xfrm>
-            <a:off x="1771650" y="6806058"/>
-            <a:ext cx="7734300" cy="784621"/>
-          </a:xfrm>
-          <a:prstGeom prst="rect">
-            <a:avLst/>
-          </a:prstGeom>
-          <a:noFill/>
-        </p:spPr>
-        <p:txBody>
-          <a:bodyPr wrap="square" lIns="0" rIns="0" tIns="0" bIns="0" anchor="t">
-            <a:noAutofit/>
-          </a:bodyPr>
-          <a:lstStyle/>
-          <a:p>
-            <a:pPr algn="l">
-              <a:lnSpc>
-                <a:spcPts val="2790"/>
-              </a:lnSpc>
-            </a:pPr>
-            <a:r>
-              <a:rPr sz="2250" b="0">
-                <a:solidFill>
-                  <a:srgbClr val="46526B"/>
-                </a:solidFill>
-                <a:latin typeface="Figtree"/>
-              </a:rPr>
-              <a:t xml:space="preserve">Para los clientes de afuera, con la versión en español a un click</a:t>
-            </a:r>
-          </a:p>
-        </p:txBody>
-      </p:sp>
-      <p:sp>
-        <p:nvSpPr>
-          <p:cNvPr id="15" name="TextBox 14"/>
-          <p:cNvSpPr txBox="1"/>
-          <p:nvPr/>
-        </p:nvSpPr>
-        <p:spPr>
-          <a:xfrm>
-            <a:off x="1771650" y="8382297"/>
-            <a:ext cx="5370760" cy="430410"/>
-          </a:xfrm>
-          <a:prstGeom prst="rect">
-            <a:avLst/>
-          </a:prstGeom>
-          <a:noFill/>
-        </p:spPr>
-        <p:txBody>
-          <a:bodyPr wrap="square" lIns="0" rIns="0" tIns="0" bIns="0" anchor="t">
-            <a:noAutofit/>
-          </a:bodyPr>
-          <a:lstStyle/>
-          <a:p>
-            <a:pPr algn="l">
-              <a:lnSpc>
-                <a:spcPts val="2790"/>
-              </a:lnSpc>
-            </a:pPr>
-            <a:r>
-              <a:rPr sz="2250" b="0">
-                <a:solidFill>
-                  <a:srgbClr val="46526B"/>
-                </a:solidFill>
-                <a:latin typeface="Figtree"/>
-              </a:rPr>
-              <a:t xml:space="preserve">Todos los meses, sin que haya que pedirlo</a:t>
-            </a:r>
-          </a:p>
-        </p:txBody>
-      </p:sp>
-      <p:sp>
-        <p:nvSpPr>
-          <p:cNvPr id="16" name="TextBox 15"/>
-          <p:cNvSpPr txBox="1"/>
-          <p:nvPr/>
-        </p:nvSpPr>
-        <p:spPr>
-          <a:xfrm>
-            <a:off x="1771650" y="9604325"/>
-            <a:ext cx="3972817" cy="430410"/>
-          </a:xfrm>
-          <a:prstGeom prst="rect">
-            <a:avLst/>
-          </a:prstGeom>
-          <a:noFill/>
-        </p:spPr>
-        <p:txBody>
-          <a:bodyPr wrap="square" lIns="0" rIns="0" tIns="0" bIns="0" anchor="t">
-            <a:noAutofit/>
-          </a:bodyPr>
-          <a:lstStyle/>
-          <a:p>
-            <a:pPr algn="l">
-              <a:lnSpc>
-                <a:spcPts val="2790"/>
-              </a:lnSpc>
-            </a:pPr>
-            <a:r>
-              <a:rPr sz="2250" b="0">
-                <a:solidFill>
-                  <a:srgbClr val="46526B"/>
-                </a:solidFill>
-                <a:latin typeface="Figtree"/>
-              </a:rPr>
-              <a:t xml:space="preserve">Apuntados a Estados Unidos</a:t>
+              <a:t xml:space="preserve">Arma empresas en Argentina para inversores del exterior. Por eso la web arranca en inglés, y por eso los anuncios de Google apuntan a Estados Unidos.</a:t>
             </a:r>
           </a:p>
         </p:txBody>
       </p:sp>
       <p:pic>
         <p:nvPicPr>
-          <p:cNvPr id="17" name="Picture 16" descr="image.png"/>
+          <p:cNvPr id="6" name="Picture 5" descr="image.png"/>
           <p:cNvPicPr>
             <a:picLocks noChangeAspect="1"/>
           </p:cNvPicPr>
@@ -4017,7 +3621,7 @@
       </p:pic>
       <p:sp>
         <p:nvSpPr>
-          <p:cNvPr id="18" name="TextBox 17"/>
+          <p:cNvPr id="7" name="TextBox 6"/>
           <p:cNvSpPr txBox="1"/>
           <p:nvPr/>
         </p:nvSpPr>
@@ -4045,7 +3649,7 @@
             <a:r>
               <a:rPr sz="1800" b="1" spc="252">
                 <a:solidFill>
-                  <a:srgbClr val="1657D0"/>
+                  <a:srgbClr val="8FD8F5"/>
                 </a:solidFill>
                 <a:latin typeface="Figtree"/>
               </a:rPr>
@@ -4054,7 +3658,7 @@
             <a:r>
               <a:rPr sz="1800" b="1" spc="252">
                 <a:solidFill>
-                  <a:srgbClr val="1657D0"/>
+                  <a:srgbClr val="8FD8F5"/>
                 </a:solidFill>
                 <a:latin typeface="Figtree"/>
               </a:rPr>
@@ -4463,7 +4067,7 @@
                 </a:solidFill>
                 <a:latin typeface="Figtree"/>
               </a:rPr>
-              <a:t xml:space="preserve">Es un estudio de Buenos Aires que les vende a inversores del exterior.</a:t>
+              <a:t xml:space="preserve">Lo primero que ve un inversor de afuera es su idioma.</a:t>
             </a:r>
           </a:p>
         </p:txBody>
@@ -4656,7 +4260,7 @@
     <p:bg>
       <p:bgPr>
         <a:solidFill>
-          <a:srgbClr val="003878"/>
+          <a:srgbClr val="FFFFFF"/>
         </a:solidFill>
         <a:effectLst/>
       </p:bgPr>
@@ -4716,102 +4320,20 @@
       </p:sp>
       <p:sp>
         <p:nvSpPr>
-          <p:cNvPr id="3" name="TextBox 2"/>
-          <p:cNvSpPr txBox="1"/>
+          <p:cNvPr id="3" name="Rectangle 2"/>
+          <p:cNvSpPr/>
           <p:nvPr/>
         </p:nvSpPr>
         <p:spPr>
           <a:xfrm>
-            <a:off x="838200" y="4503390"/>
-            <a:ext cx="9182100" cy="2232719"/>
+            <a:off x="838200" y="6468373"/>
+            <a:ext cx="4862066" cy="253746"/>
           </a:xfrm>
           <a:prstGeom prst="rect">
             <a:avLst/>
           </a:prstGeom>
-          <a:noFill/>
-        </p:spPr>
-        <p:txBody>
-          <a:bodyPr wrap="none" lIns="0" rIns="0" tIns="0" bIns="0" anchor="t">
-            <a:noAutofit/>
-          </a:bodyPr>
-          <a:lstStyle/>
-          <a:p>
-            <a:pPr algn="l">
-              <a:lnSpc>
-                <a:spcPts val="5661"/>
-              </a:lnSpc>
-            </a:pPr>
-            <a:r>
-              <a:rPr sz="5550" b="1" spc="-166">
-                <a:solidFill>
-                  <a:srgbClr val="FFFFFF"/>
-                </a:solidFill>
-                <a:latin typeface="Bricolage Grotesque"/>
-              </a:rPr>
-              <a:t xml:space="preserve">El trabajo no</a:t>
-            </a:r>
-          </a:p>
-          <a:p>
-            <a:pPr algn="l">
-              <a:lnSpc>
-                <a:spcPts val="5661"/>
-              </a:lnSpc>
-            </a:pPr>
-            <a:r>
-              <a:rPr sz="5550" b="1" spc="-166">
-                <a:solidFill>
-                  <a:srgbClr val="FFFFFF"/>
-                </a:solidFill>
-                <a:latin typeface="Bricolage Grotesque"/>
-              </a:rPr>
-              <a:t xml:space="preserve">termina cuando</a:t>
-            </a:r>
-          </a:p>
-          <a:p>
-            <a:pPr algn="l">
-              <a:lnSpc>
-                <a:spcPts val="5661"/>
-              </a:lnSpc>
-            </a:pPr>
-            <a:r>
-              <a:rPr sz="5550" b="1" spc="-166">
-                <a:solidFill>
-                  <a:srgbClr val="63C8F2"/>
-                </a:solidFill>
-                <a:latin typeface="Bricolage Grotesque"/>
-              </a:rPr>
-              <a:t xml:space="preserve">entregás</a:t>
-            </a:r>
-            <a:r>
-              <a:rPr sz="5550" b="1" spc="-166">
-                <a:solidFill>
-                  <a:srgbClr val="FFFFFF"/>
-                </a:solidFill>
-                <a:latin typeface="Bricolage Grotesque"/>
-              </a:rPr>
-              <a:t xml:space="preserve">.</a:t>
-            </a:r>
-          </a:p>
-        </p:txBody>
-      </p:sp>
-      <p:sp>
-        <p:nvSpPr>
-          <p:cNvPr id="4" name="Rounded Rectangle 3"/>
-          <p:cNvSpPr/>
-          <p:nvPr/>
-        </p:nvSpPr>
-        <p:spPr>
-          <a:xfrm>
-            <a:off x="838200" y="7079009"/>
-            <a:ext cx="5870376" cy="885825"/>
-          </a:xfrm>
-          <a:prstGeom prst="roundRect">
-            <a:avLst>
-              <a:gd name="adj" fmla="val 50000"/>
-            </a:avLst>
-          </a:prstGeom>
           <a:solidFill>
-            <a:srgbClr val="1657D0"/>
+            <a:srgbClr val="A8E1F8"/>
           </a:solidFill>
           <a:ln>
             <a:noFill/>
@@ -4842,7 +4364,133 @@
       </p:sp>
       <p:sp>
         <p:nvSpPr>
-          <p:cNvPr id="5" name="TextBox 4"/>
+          <p:cNvPr id="4" name="TextBox 3"/>
+          <p:cNvSpPr txBox="1"/>
+          <p:nvPr/>
+        </p:nvSpPr>
+        <p:spPr>
+          <a:xfrm>
+            <a:off x="838200" y="4503390"/>
+            <a:ext cx="9182100" cy="2232719"/>
+          </a:xfrm>
+          <a:prstGeom prst="rect">
+            <a:avLst/>
+          </a:prstGeom>
+          <a:noFill/>
+        </p:spPr>
+        <p:txBody>
+          <a:bodyPr wrap="none" lIns="0" rIns="0" tIns="0" bIns="0" anchor="t">
+            <a:noAutofit/>
+          </a:bodyPr>
+          <a:lstStyle/>
+          <a:p>
+            <a:pPr algn="l">
+              <a:lnSpc>
+                <a:spcPts val="5661"/>
+              </a:lnSpc>
+            </a:pPr>
+            <a:r>
+              <a:rPr sz="5550" b="1" spc="-166">
+                <a:solidFill>
+                  <a:srgbClr val="0A1B33"/>
+                </a:solidFill>
+                <a:latin typeface="Bricolage Grotesque"/>
+              </a:rPr>
+              <a:t xml:space="preserve">Tu web tiene que</a:t>
+            </a:r>
+          </a:p>
+          <a:p>
+            <a:pPr algn="l">
+              <a:lnSpc>
+                <a:spcPts val="5661"/>
+              </a:lnSpc>
+            </a:pPr>
+            <a:r>
+              <a:rPr sz="5550" b="1" spc="-166">
+                <a:solidFill>
+                  <a:srgbClr val="0A1B33"/>
+                </a:solidFill>
+                <a:latin typeface="Bricolage Grotesque"/>
+              </a:rPr>
+              <a:t xml:space="preserve">hablar el idioma de</a:t>
+            </a:r>
+          </a:p>
+          <a:p>
+            <a:pPr algn="l">
+              <a:lnSpc>
+                <a:spcPts val="5661"/>
+              </a:lnSpc>
+            </a:pPr>
+            <a:r>
+              <a:rPr sz="5550" b="1" spc="-166">
+                <a:solidFill>
+                  <a:srgbClr val="0A1B33"/>
+                </a:solidFill>
+                <a:latin typeface="Bricolage Grotesque"/>
+              </a:rPr>
+              <a:t xml:space="preserve">quien te compra</a:t>
+            </a:r>
+            <a:r>
+              <a:rPr sz="5550" b="1" spc="-166">
+                <a:solidFill>
+                  <a:srgbClr val="0A1B33"/>
+                </a:solidFill>
+                <a:latin typeface="Bricolage Grotesque"/>
+              </a:rPr>
+              <a:t xml:space="preserve">.</a:t>
+            </a:r>
+          </a:p>
+        </p:txBody>
+      </p:sp>
+      <p:sp>
+        <p:nvSpPr>
+          <p:cNvPr id="5" name="Rounded Rectangle 4"/>
+          <p:cNvSpPr/>
+          <p:nvPr/>
+        </p:nvSpPr>
+        <p:spPr>
+          <a:xfrm>
+            <a:off x="838200" y="7079009"/>
+            <a:ext cx="5870376" cy="885825"/>
+          </a:xfrm>
+          <a:prstGeom prst="roundRect">
+            <a:avLst>
+              <a:gd name="adj" fmla="val 50000"/>
+            </a:avLst>
+          </a:prstGeom>
+          <a:solidFill>
+            <a:srgbClr val="1657D0"/>
+          </a:solidFill>
+          <a:ln>
+            <a:noFill/>
+          </a:ln>
+          <a:effectLst/>
+        </p:spPr>
+        <p:style>
+          <a:lnRef idx="1">
+            <a:schemeClr val="accent1"/>
+          </a:lnRef>
+          <a:fillRef idx="3">
+            <a:schemeClr val="accent1"/>
+          </a:fillRef>
+          <a:effectRef idx="2">
+            <a:schemeClr val="accent1"/>
+          </a:effectRef>
+          <a:fontRef idx="minor">
+            <a:schemeClr val="lt1"/>
+          </a:fontRef>
+        </p:style>
+        <p:txBody>
+          <a:bodyPr rtlCol="0" anchor="ctr"/>
+          <a:lstStyle/>
+          <a:p>
+            <a:pPr algn="ctr"/>
+          </a:p>
+        </p:txBody>
+      </p:sp>
+      <p:sp>
+        <p:nvSpPr>
+          <p:cNvPr id="6" name="TextBox 5"/>
           <p:cNvSpPr txBox="1"/>
           <p:nvPr/>
         </p:nvSpPr>
@@ -4881,7 +4529,7 @@
       </p:sp>
       <p:pic>
         <p:nvPicPr>
-          <p:cNvPr id="6" name="Picture 5" descr="image.png"/>
+          <p:cNvPr id="7" name="Picture 6" descr="image.png"/>
           <p:cNvPicPr>
             <a:picLocks noChangeAspect="1"/>
           </p:cNvPicPr>

</xml_diff>